<commit_message>
Remove the Rise line from slide 8.
The stakeholder deck ends on the three decisions.

Co-authored-by: KeithByne <KeithByne@users.noreply.github.com>
</commit_message>
<xml_diff>
--- a/portfolio/job-aid-safe-ai/before-you-paste.pptx
+++ b/portfolio/job-aid-safe-ai/before-you-paste.pptx
@@ -8862,51 +8862,6 @@
                 <a:latin typeface="League Gothic" pitchFamily="2" charset="0"/>
               </a:rPr>
               <a:t>Click</a:t>
-            </a:r>
-          </a:p>
-        </p:txBody>
-      </p:sp>
-      <p:sp>
-        <p:nvSpPr>
-          <p:cNvPr id="9" name="TextBox 8">
-            <a:extLst>
-              <a:ext uri="{FF2B5EF4-FFF2-40B4-BE49-F238E27FC236}">
-                <a16:creationId xmlns:a16="http://schemas.microsoft.com/office/drawing/2014/main" id="{EA14BE28-6A42-E70F-4A89-F2B575FDD066}"/>
-              </a:ext>
-            </a:extLst>
-          </p:cNvPr>
-          <p:cNvSpPr txBox="1"/>
-          <p:nvPr/>
-        </p:nvSpPr>
-        <p:spPr>
-          <a:xfrm>
-            <a:off x="711200" y="6248400"/>
-            <a:ext cx="10769600" cy="369332"/>
-          </a:xfrm>
-          <a:prstGeom prst="rect">
-            <a:avLst/>
-          </a:prstGeom>
-          <a:noFill/>
-        </p:spPr>
-        <p:txBody>
-          <a:bodyPr vert="horz" wrap="square" lIns="0" tIns="0" rIns="0" bIns="0" rtlCol="0">
-            <a:noAutofit/>
-          </a:bodyPr>
-          <a:lstStyle/>
-          <a:p>
-            <a:pPr>
-              <a:lnSpc>
-                <a:spcPct val="150000"/>
-              </a:lnSpc>
-            </a:pPr>
-            <a:r>
-              <a:rPr lang="en-US" sz="1600">
-                <a:solidFill>
-                  <a:srgbClr val="3B3B3B"/>
-                </a:solidFill>
-                <a:latin typeface="Open Sauce One" pitchFamily="2" charset="0"/>
-              </a:rPr>
-              <a:t>Then build the Rise module from the existing script.</a:t>
             </a:r>
           </a:p>
         </p:txBody>

</xml_diff>